<commit_message>
Commit 18 October 2024 - final commit
</commit_message>
<xml_diff>
--- a/PROJECT FSR.pptx
+++ b/PROJECT FSR.pptx
@@ -27,7 +27,7 @@
     <p:sldId id="342" r:id="rId15"/>
     <p:sldId id="363" r:id="rId16"/>
     <p:sldId id="365" r:id="rId17"/>
-    <p:sldId id="364" r:id="rId18"/>
+    <p:sldId id="367" r:id="rId18"/>
     <p:sldId id="335" r:id="rId19"/>
     <p:sldId id="343" r:id="rId20"/>
     <p:sldId id="346" r:id="rId21"/>
@@ -162,6 +162,96 @@
 </p188:authorLst>
 </file>
 
+<file path=ppt/changesInfos/changesInfo1.xml><?xml version="1.0" encoding="utf-8"?>
+<pc:chgInfo xmlns:a="http://schemas.openxmlformats.org/drawingml/2006/main" xmlns:r="http://schemas.openxmlformats.org/officeDocument/2006/relationships" xmlns:ac="http://schemas.microsoft.com/office/drawing/2013/main/command" xmlns:pc="http://schemas.microsoft.com/office/powerpoint/2013/main/command">
+  <pc:docChgLst>
+    <pc:chgData name="Paolo Maisto" userId="5631adec-571f-44b6-80d8-06a6dd3ca642" providerId="ADAL" clId="{40B847D3-F178-48FE-9B4C-1C594C208D8D}"/>
+    <pc:docChg chg="modSld">
+      <pc:chgData name="Paolo Maisto" userId="5631adec-571f-44b6-80d8-06a6dd3ca642" providerId="ADAL" clId="{40B847D3-F178-48FE-9B4C-1C594C208D8D}" dt="2024-10-18T09:23:08.367" v="26" actId="14100"/>
+      <pc:docMkLst>
+        <pc:docMk/>
+      </pc:docMkLst>
+      <pc:sldChg chg="modSp mod">
+        <pc:chgData name="Paolo Maisto" userId="5631adec-571f-44b6-80d8-06a6dd3ca642" providerId="ADAL" clId="{40B847D3-F178-48FE-9B4C-1C594C208D8D}" dt="2024-10-18T08:46:39.437" v="3" actId="20577"/>
+        <pc:sldMkLst>
+          <pc:docMk/>
+          <pc:sldMk cId="4141889126" sldId="341"/>
+        </pc:sldMkLst>
+        <pc:spChg chg="mod">
+          <ac:chgData name="Paolo Maisto" userId="5631adec-571f-44b6-80d8-06a6dd3ca642" providerId="ADAL" clId="{40B847D3-F178-48FE-9B4C-1C594C208D8D}" dt="2024-10-18T08:46:39.437" v="3" actId="20577"/>
+          <ac:spMkLst>
+            <pc:docMk/>
+            <pc:sldMk cId="4141889126" sldId="341"/>
+            <ac:spMk id="22" creationId="{27C2FD63-11B0-6187-39D6-F0196E58A129}"/>
+          </ac:spMkLst>
+        </pc:spChg>
+      </pc:sldChg>
+      <pc:sldChg chg="modSp mod">
+        <pc:chgData name="Paolo Maisto" userId="5631adec-571f-44b6-80d8-06a6dd3ca642" providerId="ADAL" clId="{40B847D3-F178-48FE-9B4C-1C594C208D8D}" dt="2024-10-18T08:47:12.639" v="18" actId="14100"/>
+        <pc:sldMkLst>
+          <pc:docMk/>
+          <pc:sldMk cId="2113858536" sldId="343"/>
+        </pc:sldMkLst>
+        <pc:spChg chg="mod">
+          <ac:chgData name="Paolo Maisto" userId="5631adec-571f-44b6-80d8-06a6dd3ca642" providerId="ADAL" clId="{40B847D3-F178-48FE-9B4C-1C594C208D8D}" dt="2024-10-18T08:47:12.639" v="18" actId="14100"/>
+          <ac:spMkLst>
+            <pc:docMk/>
+            <pc:sldMk cId="2113858536" sldId="343"/>
+            <ac:spMk id="45" creationId="{E73F7AF4-55FC-598D-4D65-F79829B73034}"/>
+          </ac:spMkLst>
+        </pc:spChg>
+      </pc:sldChg>
+      <pc:sldChg chg="modSp mod">
+        <pc:chgData name="Paolo Maisto" userId="5631adec-571f-44b6-80d8-06a6dd3ca642" providerId="ADAL" clId="{40B847D3-F178-48FE-9B4C-1C594C208D8D}" dt="2024-10-18T09:22:36.874" v="22" actId="14100"/>
+        <pc:sldMkLst>
+          <pc:docMk/>
+          <pc:sldMk cId="4126567776" sldId="348"/>
+        </pc:sldMkLst>
+        <pc:spChg chg="mod">
+          <ac:chgData name="Paolo Maisto" userId="5631adec-571f-44b6-80d8-06a6dd3ca642" providerId="ADAL" clId="{40B847D3-F178-48FE-9B4C-1C594C208D8D}" dt="2024-10-18T09:22:31.687" v="20" actId="14100"/>
+          <ac:spMkLst>
+            <pc:docMk/>
+            <pc:sldMk cId="4126567776" sldId="348"/>
+            <ac:spMk id="13" creationId="{61461817-D1BC-7EC6-8D09-CF77920D840B}"/>
+          </ac:spMkLst>
+        </pc:spChg>
+        <pc:spChg chg="mod">
+          <ac:chgData name="Paolo Maisto" userId="5631adec-571f-44b6-80d8-06a6dd3ca642" providerId="ADAL" clId="{40B847D3-F178-48FE-9B4C-1C594C208D8D}" dt="2024-10-18T09:22:36.874" v="22" actId="14100"/>
+          <ac:spMkLst>
+            <pc:docMk/>
+            <pc:sldMk cId="4126567776" sldId="348"/>
+            <ac:spMk id="36" creationId="{425AC425-88CD-E5F5-3C75-33F4F2960160}"/>
+          </ac:spMkLst>
+        </pc:spChg>
+      </pc:sldChg>
+      <pc:sldChg chg="modSp mod">
+        <pc:chgData name="Paolo Maisto" userId="5631adec-571f-44b6-80d8-06a6dd3ca642" providerId="ADAL" clId="{40B847D3-F178-48FE-9B4C-1C594C208D8D}" dt="2024-10-18T09:23:08.367" v="26" actId="14100"/>
+        <pc:sldMkLst>
+          <pc:docMk/>
+          <pc:sldMk cId="1616334452" sldId="351"/>
+        </pc:sldMkLst>
+        <pc:spChg chg="mod">
+          <ac:chgData name="Paolo Maisto" userId="5631adec-571f-44b6-80d8-06a6dd3ca642" providerId="ADAL" clId="{40B847D3-F178-48FE-9B4C-1C594C208D8D}" dt="2024-10-18T09:22:59.057" v="24" actId="14100"/>
+          <ac:spMkLst>
+            <pc:docMk/>
+            <pc:sldMk cId="1616334452" sldId="351"/>
+            <ac:spMk id="17" creationId="{A6A09F0C-3EB8-F05A-90AB-B08FC7EB3C23}"/>
+          </ac:spMkLst>
+        </pc:spChg>
+        <pc:spChg chg="mod">
+          <ac:chgData name="Paolo Maisto" userId="5631adec-571f-44b6-80d8-06a6dd3ca642" providerId="ADAL" clId="{40B847D3-F178-48FE-9B4C-1C594C208D8D}" dt="2024-10-18T09:23:08.367" v="26" actId="14100"/>
+          <ac:spMkLst>
+            <pc:docMk/>
+            <pc:sldMk cId="1616334452" sldId="351"/>
+            <ac:spMk id="22" creationId="{8FABE609-0B1C-BE34-73FE-07AF36181DF8}"/>
+          </ac:spMkLst>
+        </pc:spChg>
+      </pc:sldChg>
+    </pc:docChg>
+  </pc:docChgLst>
+</pc:chgInfo>
+</file>
+
 <file path=ppt/handoutMasters/handoutMaster1.xml><?xml version="1.0" encoding="utf-8"?>
 <p:handoutMaster xmlns:a="http://schemas.openxmlformats.org/drawingml/2006/main" xmlns:r="http://schemas.openxmlformats.org/officeDocument/2006/relationships" xmlns:p="http://schemas.openxmlformats.org/presentationml/2006/main">
   <p:cSld>
@@ -244,7 +334,7 @@
           <a:p>
             <a:fld id="{0914F915-DDDE-4CAA-895D-614564BB8837}" type="datetimeFigureOut">
               <a:rPr lang="en-GB" smtClean="0"/>
-              <a:t>10/10/2024</a:t>
+              <a:t>18/10/2024</a:t>
             </a:fld>
             <a:endParaRPr lang="en-GB"/>
           </a:p>
@@ -409,7 +499,7 @@
           <a:p>
             <a:fld id="{A9D4C5A5-33D0-4441-96FE-163C8B7C9D3F}" type="datetimeFigureOut">
               <a:rPr lang="en-GB" smtClean="0"/>
-              <a:t>10/10/2024</a:t>
+              <a:t>18/10/2024</a:t>
             </a:fld>
             <a:endParaRPr lang="en-GB"/>
           </a:p>
@@ -4344,7 +4434,7 @@
           <a:p>
             <a:fld id="{2C790A91-0F3D-9944-94EF-F5C93CDE0643}" type="datetimeFigureOut">
               <a:rPr lang="it-IT" smtClean="0"/>
-              <a:t>10/10/2024</a:t>
+              <a:t>18/10/2024</a:t>
             </a:fld>
             <a:endParaRPr lang="it-IT"/>
           </a:p>
@@ -4524,7 +4614,7 @@
           <a:p>
             <a:fld id="{2C790A91-0F3D-9944-94EF-F5C93CDE0643}" type="datetimeFigureOut">
               <a:rPr lang="it-IT" smtClean="0"/>
-              <a:t>10/10/2024</a:t>
+              <a:t>18/10/2024</a:t>
             </a:fld>
             <a:endParaRPr lang="it-IT"/>
           </a:p>
@@ -4714,7 +4804,7 @@
           <a:p>
             <a:fld id="{2C790A91-0F3D-9944-94EF-F5C93CDE0643}" type="datetimeFigureOut">
               <a:rPr lang="it-IT" smtClean="0"/>
-              <a:t>10/10/2024</a:t>
+              <a:t>18/10/2024</a:t>
             </a:fld>
             <a:endParaRPr lang="it-IT"/>
           </a:p>
@@ -4894,7 +4984,7 @@
           <a:p>
             <a:fld id="{2C790A91-0F3D-9944-94EF-F5C93CDE0643}" type="datetimeFigureOut">
               <a:rPr lang="it-IT" smtClean="0"/>
-              <a:t>10/10/2024</a:t>
+              <a:t>18/10/2024</a:t>
             </a:fld>
             <a:endParaRPr lang="it-IT"/>
           </a:p>
@@ -5151,7 +5241,7 @@
           <a:p>
             <a:fld id="{2C790A91-0F3D-9944-94EF-F5C93CDE0643}" type="datetimeFigureOut">
               <a:rPr lang="it-IT" smtClean="0"/>
-              <a:t>10/10/2024</a:t>
+              <a:t>18/10/2024</a:t>
             </a:fld>
             <a:endParaRPr lang="it-IT"/>
           </a:p>
@@ -5448,7 +5538,7 @@
           <a:p>
             <a:fld id="{2C790A91-0F3D-9944-94EF-F5C93CDE0643}" type="datetimeFigureOut">
               <a:rPr lang="it-IT" smtClean="0"/>
-              <a:t>10/10/2024</a:t>
+              <a:t>18/10/2024</a:t>
             </a:fld>
             <a:endParaRPr lang="it-IT"/>
           </a:p>
@@ -5879,7 +5969,7 @@
           <a:p>
             <a:fld id="{2C790A91-0F3D-9944-94EF-F5C93CDE0643}" type="datetimeFigureOut">
               <a:rPr lang="it-IT" smtClean="0"/>
-              <a:t>10/10/2024</a:t>
+              <a:t>18/10/2024</a:t>
             </a:fld>
             <a:endParaRPr lang="it-IT"/>
           </a:p>
@@ -6008,7 +6098,7 @@
           <a:p>
             <a:fld id="{2C790A91-0F3D-9944-94EF-F5C93CDE0643}" type="datetimeFigureOut">
               <a:rPr lang="it-IT" smtClean="0"/>
-              <a:t>10/10/2024</a:t>
+              <a:t>18/10/2024</a:t>
             </a:fld>
             <a:endParaRPr lang="it-IT"/>
           </a:p>
@@ -6115,7 +6205,7 @@
           <a:p>
             <a:fld id="{2C790A91-0F3D-9944-94EF-F5C93CDE0643}" type="datetimeFigureOut">
               <a:rPr lang="it-IT" smtClean="0"/>
-              <a:t>10/10/2024</a:t>
+              <a:t>18/10/2024</a:t>
             </a:fld>
             <a:endParaRPr lang="it-IT"/>
           </a:p>
@@ -6402,7 +6492,7 @@
           <a:p>
             <a:fld id="{2C790A91-0F3D-9944-94EF-F5C93CDE0643}" type="datetimeFigureOut">
               <a:rPr lang="it-IT" smtClean="0"/>
-              <a:t>10/10/2024</a:t>
+              <a:t>18/10/2024</a:t>
             </a:fld>
             <a:endParaRPr lang="it-IT"/>
           </a:p>
@@ -6666,7 +6756,7 @@
           <a:p>
             <a:fld id="{2C790A91-0F3D-9944-94EF-F5C93CDE0643}" type="datetimeFigureOut">
               <a:rPr lang="it-IT" smtClean="0"/>
-              <a:t>10/10/2024</a:t>
+              <a:t>18/10/2024</a:t>
             </a:fld>
             <a:endParaRPr lang="it-IT"/>
           </a:p>
@@ -6889,7 +6979,7 @@
           <a:p>
             <a:fld id="{2C790A91-0F3D-9944-94EF-F5C93CDE0643}" type="datetimeFigureOut">
               <a:rPr lang="it-IT" smtClean="0"/>
-              <a:t>10/10/2024</a:t>
+              <a:t>18/10/2024</a:t>
             </a:fld>
             <a:endParaRPr lang="it-IT"/>
           </a:p>
@@ -9047,7 +9137,7 @@
           <a:p>
             <a:r>
               <a:rPr lang="en-US" sz="1800" dirty="0"/>
-              <a:t>Obtained path, which allows to go from the initial point to the final point, is constituted by broken lines </a:t>
+              <a:t>Obtained path, which allows to go from the initial point to the final point, is made by broken lines </a:t>
             </a:r>
           </a:p>
           <a:p>
@@ -14568,7 +14658,7 @@
             </p:nvSpPr>
             <p:spPr>
               <a:xfrm>
-                <a:off x="5606794" y="4768645"/>
+                <a:off x="4782447" y="4722771"/>
                 <a:ext cx="5704704" cy="1767663"/>
               </a:xfrm>
               <a:prstGeom prst="rect">
@@ -16356,7 +16446,7 @@
             </p:nvSpPr>
             <p:spPr>
               <a:xfrm>
-                <a:off x="5606794" y="4768645"/>
+                <a:off x="4782447" y="4722771"/>
                 <a:ext cx="5704704" cy="1767663"/>
               </a:xfrm>
               <a:prstGeom prst="rect">
@@ -16365,7 +16455,7 @@
               <a:blipFill>
                 <a:blip r:embed="rId4"/>
                 <a:stretch>
-                  <a:fillRect r="-9402"/>
+                  <a:fillRect r="-9519"/>
                 </a:stretch>
               </a:blipFill>
             </p:spPr>
@@ -16400,8 +16490,8 @@
             </p:nvSpPr>
             <p:spPr>
               <a:xfrm>
-                <a:off x="681925" y="4399606"/>
-                <a:ext cx="6295036" cy="646331"/>
+                <a:off x="880502" y="4399606"/>
+                <a:ext cx="6295036" cy="923330"/>
               </a:xfrm>
               <a:prstGeom prst="rect">
                 <a:avLst/>
@@ -16551,6 +16641,24 @@
                                             </m:r>
                                           </m:sub>
                                         </m:sSub>
+                                        <m:r>
+                                          <a:rPr lang="it-IT" b="0" i="1" smtClean="0">
+                                            <a:latin typeface="Cambria Math" panose="02040503050406030204" pitchFamily="18" charset="0"/>
+                                          </a:rPr>
+                                          <m:t>(</m:t>
+                                        </m:r>
+                                        <m:r>
+                                          <a:rPr lang="it-IT" b="0" i="1" smtClean="0">
+                                            <a:latin typeface="Cambria Math" panose="02040503050406030204" pitchFamily="18" charset="0"/>
+                                          </a:rPr>
+                                          <m:t>𝑡</m:t>
+                                        </m:r>
+                                        <m:r>
+                                          <a:rPr lang="it-IT" b="0" i="1" smtClean="0">
+                                            <a:latin typeface="Cambria Math" panose="02040503050406030204" pitchFamily="18" charset="0"/>
+                                          </a:rPr>
+                                          <m:t>)</m:t>
+                                        </m:r>
                                       </m:e>
                                       <m:e>
                                         <m:sSub>
@@ -16578,6 +16686,24 @@
                                             </m:r>
                                           </m:sub>
                                         </m:sSub>
+                                        <m:r>
+                                          <a:rPr lang="it-IT" b="0" i="1" smtClean="0">
+                                            <a:latin typeface="Cambria Math" panose="02040503050406030204" pitchFamily="18" charset="0"/>
+                                          </a:rPr>
+                                          <m:t>(</m:t>
+                                        </m:r>
+                                        <m:r>
+                                          <a:rPr lang="it-IT" b="0" i="1" smtClean="0">
+                                            <a:latin typeface="Cambria Math" panose="02040503050406030204" pitchFamily="18" charset="0"/>
+                                          </a:rPr>
+                                          <m:t>𝑡</m:t>
+                                        </m:r>
+                                        <m:r>
+                                          <a:rPr lang="it-IT" b="0" i="1" smtClean="0">
+                                            <a:latin typeface="Cambria Math" panose="02040503050406030204" pitchFamily="18" charset="0"/>
+                                          </a:rPr>
+                                          <m:t>)</m:t>
+                                        </m:r>
                                       </m:e>
                                     </m:mr>
                                   </m:m>
@@ -16626,6 +16752,24 @@
                                             </m:r>
                                           </m:sub>
                                         </m:sSub>
+                                        <m:r>
+                                          <a:rPr lang="it-IT" b="0" i="1" smtClean="0">
+                                            <a:latin typeface="Cambria Math" panose="02040503050406030204" pitchFamily="18" charset="0"/>
+                                          </a:rPr>
+                                          <m:t>(</m:t>
+                                        </m:r>
+                                        <m:r>
+                                          <a:rPr lang="it-IT" b="0" i="1" smtClean="0">
+                                            <a:latin typeface="Cambria Math" panose="02040503050406030204" pitchFamily="18" charset="0"/>
+                                          </a:rPr>
+                                          <m:t>𝑡</m:t>
+                                        </m:r>
+                                        <m:r>
+                                          <a:rPr lang="it-IT" b="0" i="1" smtClean="0">
+                                            <a:latin typeface="Cambria Math" panose="02040503050406030204" pitchFamily="18" charset="0"/>
+                                          </a:rPr>
+                                          <m:t>)</m:t>
+                                        </m:r>
                                       </m:e>
                                       <m:e>
                                         <m:sSub>
@@ -16653,6 +16797,24 @@
                                             </m:r>
                                           </m:sub>
                                         </m:sSub>
+                                        <m:r>
+                                          <a:rPr lang="it-IT" b="0" i="1" smtClean="0">
+                                            <a:latin typeface="Cambria Math" panose="02040503050406030204" pitchFamily="18" charset="0"/>
+                                          </a:rPr>
+                                          <m:t>(</m:t>
+                                        </m:r>
+                                        <m:r>
+                                          <a:rPr lang="it-IT" b="0" i="1" smtClean="0">
+                                            <a:latin typeface="Cambria Math" panose="02040503050406030204" pitchFamily="18" charset="0"/>
+                                          </a:rPr>
+                                          <m:t>𝑡</m:t>
+                                        </m:r>
+                                        <m:r>
+                                          <a:rPr lang="it-IT" b="0" i="1" smtClean="0">
+                                            <a:latin typeface="Cambria Math" panose="02040503050406030204" pitchFamily="18" charset="0"/>
+                                          </a:rPr>
+                                          <m:t>)</m:t>
+                                        </m:r>
                                       </m:e>
                                     </m:mr>
                                   </m:m>
@@ -16683,7 +16845,15 @@
                   <a:rPr lang="en-US" dirty="0">
                     <a:latin typeface="Century Gothic" panose="020B0502020202020204" pitchFamily="34" charset="0"/>
                   </a:rPr>
-                  <a:t>to be given input to the controller</a:t>
+                  <a:t>to be given</a:t>
+                </a:r>
+              </a:p>
+              <a:p>
+                <a:r>
+                  <a:rPr lang="en-US" dirty="0">
+                    <a:latin typeface="Century Gothic" panose="020B0502020202020204" pitchFamily="34" charset="0"/>
+                  </a:rPr>
+                  <a:t>input to the controller</a:t>
                 </a:r>
                 <a:endParaRPr lang="it-IT" dirty="0">
                   <a:latin typeface="Century Gothic" panose="020B0502020202020204" pitchFamily="34" charset="0"/>
@@ -16709,8 +16879,8 @@
             </p:nvSpPr>
             <p:spPr>
               <a:xfrm>
-                <a:off x="681925" y="4399606"/>
-                <a:ext cx="6295036" cy="646331"/>
+                <a:off x="880502" y="4399606"/>
+                <a:ext cx="6295036" cy="923330"/>
               </a:xfrm>
               <a:prstGeom prst="rect">
                 <a:avLst/>
@@ -16718,7 +16888,7 @@
               <a:blipFill>
                 <a:blip r:embed="rId5"/>
                 <a:stretch>
-                  <a:fillRect l="-871" t="-5660" b="-14151"/>
+                  <a:fillRect l="-774" t="-3974" b="-9934"/>
                 </a:stretch>
               </a:blipFill>
             </p:spPr>
@@ -16893,12 +17063,12 @@
         </p:nvCxnSpPr>
         <p:spPr>
           <a:xfrm rot="5400000">
-            <a:off x="4961700" y="2638743"/>
-            <a:ext cx="2282091" cy="991904"/>
+            <a:off x="4803896" y="2811061"/>
+            <a:ext cx="2612215" cy="977391"/>
           </a:xfrm>
           <a:prstGeom prst="bentConnector3">
             <a:avLst>
-              <a:gd name="adj1" fmla="val 15019"/>
+              <a:gd name="adj1" fmla="val 34373"/>
             </a:avLst>
           </a:prstGeom>
           <a:ln w="28575">
@@ -17072,7 +17242,7 @@
             </p:nvSpPr>
             <p:spPr>
               <a:xfrm>
-                <a:off x="6869741" y="1838064"/>
+                <a:off x="6869741" y="1822022"/>
                 <a:ext cx="3401433" cy="738664"/>
               </a:xfrm>
               <a:prstGeom prst="rect">
@@ -17194,14 +17364,14 @@
             </p:nvSpPr>
             <p:spPr>
               <a:xfrm>
-                <a:off x="6869741" y="1838064"/>
+                <a:off x="6869741" y="1822022"/>
                 <a:ext cx="3401433" cy="738664"/>
               </a:xfrm>
               <a:prstGeom prst="rect">
                 <a:avLst/>
               </a:prstGeom>
               <a:blipFill>
-                <a:blip r:embed="rId9"/>
+                <a:blip r:embed="rId8"/>
                 <a:stretch>
                   <a:fillRect l="-538" t="-1653" b="-7438"/>
                 </a:stretch>
@@ -17374,261 +17544,70 @@
           </a:p>
         </p:txBody>
       </p:sp>
-      <mc:AlternateContent xmlns:mc="http://schemas.openxmlformats.org/markup-compatibility/2006" xmlns:a14="http://schemas.microsoft.com/office/drawing/2010/main">
-        <mc:Choice Requires="a14">
-          <p:sp>
-            <p:nvSpPr>
-              <p:cNvPr id="20" name="CasellaDiTesto 19">
-                <a:extLst>
-                  <a:ext uri="{FF2B5EF4-FFF2-40B4-BE49-F238E27FC236}">
-                    <a16:creationId xmlns:a16="http://schemas.microsoft.com/office/drawing/2014/main" id="{3B971298-8E67-0CC5-FD8C-AF79D7A1C506}"/>
-                  </a:ext>
-                </a:extLst>
-              </p:cNvPr>
-              <p:cNvSpPr txBox="1"/>
-              <p:nvPr/>
-            </p:nvSpPr>
-            <p:spPr>
-              <a:xfrm>
-                <a:off x="1364344" y="2595111"/>
-                <a:ext cx="4242450" cy="1169551"/>
-              </a:xfrm>
-              <a:prstGeom prst="rect">
-                <a:avLst/>
-              </a:prstGeom>
-              <a:noFill/>
-            </p:spPr>
-            <p:txBody>
-              <a:bodyPr wrap="square">
-                <a:spAutoFit/>
-              </a:bodyPr>
-              <a:lstStyle/>
-              <a:p>
-                <a:r>
-                  <a:rPr lang="en-US" altLang="it-IT" sz="1400" dirty="0">
-                    <a:latin typeface="Century Gothic" panose="020B0502020202020204" pitchFamily="34" charset="0"/>
-                  </a:rPr>
-                  <a:t>T</a:t>
-                </a:r>
-                <a:r>
-                  <a:rPr kumimoji="0" lang="en-US" altLang="it-IT" sz="1400" b="0" i="0" u="none" strike="noStrike" cap="none" normalizeH="0" baseline="0" dirty="0">
-                    <a:ln>
-                      <a:noFill/>
-                    </a:ln>
-                    <a:solidFill>
-                      <a:schemeClr val="tx1"/>
-                    </a:solidFill>
-                    <a:effectLst/>
-                    <a:latin typeface="Century Gothic" panose="020B0502020202020204" pitchFamily="34" charset="0"/>
-                  </a:rPr>
-                  <a:t>ime law was defined as a function that maps time </a:t>
-                </a:r>
-                <a14:m>
-                  <m:oMath xmlns:m="http://schemas.openxmlformats.org/officeDocument/2006/math">
-                    <m:r>
-                      <a:rPr kumimoji="0" lang="it-IT" altLang="it-IT" sz="1400" b="0" i="1" u="none" strike="noStrike" cap="none" normalizeH="0" baseline="0" smtClean="0">
-                        <a:ln>
-                          <a:noFill/>
-                        </a:ln>
-                        <a:solidFill>
-                          <a:schemeClr val="tx1"/>
-                        </a:solidFill>
-                        <a:effectLst/>
-                        <a:latin typeface="Cambria Math" panose="02040503050406030204" pitchFamily="18" charset="0"/>
-                      </a:rPr>
-                      <m:t>𝑡</m:t>
-                    </m:r>
-                  </m:oMath>
-                </a14:m>
-                <a:r>
-                  <a:rPr kumimoji="0" lang="en-US" altLang="it-IT" sz="1400" b="0" i="0" u="none" strike="noStrike" cap="none" normalizeH="0" baseline="0" dirty="0">
-                    <a:ln>
-                      <a:noFill/>
-                    </a:ln>
-                    <a:solidFill>
-                      <a:schemeClr val="tx1"/>
-                    </a:solidFill>
-                    <a:effectLst/>
-                    <a:latin typeface="Century Gothic" panose="020B0502020202020204" pitchFamily="34" charset="0"/>
-                  </a:rPr>
-                  <a:t> to </a:t>
-                </a:r>
-                <a:r>
-                  <a:rPr lang="en-US" altLang="it-IT" sz="1400" dirty="0">
-                    <a:latin typeface="Century Gothic" panose="020B0502020202020204" pitchFamily="34" charset="0"/>
-                  </a:rPr>
-                  <a:t>the arclength </a:t>
-                </a:r>
-                <a14:m>
-                  <m:oMath xmlns:m="http://schemas.openxmlformats.org/officeDocument/2006/math">
-                    <m:r>
-                      <a:rPr kumimoji="0" lang="it-IT" altLang="it-IT" sz="1400" b="0" i="1" u="none" strike="noStrike" cap="none" normalizeH="0" baseline="0" smtClean="0">
-                        <a:ln>
-                          <a:noFill/>
-                        </a:ln>
-                        <a:solidFill>
-                          <a:schemeClr val="tx1"/>
-                        </a:solidFill>
-                        <a:effectLst/>
-                        <a:latin typeface="Cambria Math" panose="02040503050406030204" pitchFamily="18" charset="0"/>
-                      </a:rPr>
-                      <m:t>𝑠</m:t>
-                    </m:r>
-                  </m:oMath>
-                </a14:m>
-                <a:r>
-                  <a:rPr kumimoji="0" lang="en-US" altLang="it-IT" sz="1400" b="0" i="0" u="none" strike="noStrike" cap="none" normalizeH="0" baseline="0" dirty="0">
-                    <a:ln>
-                      <a:noFill/>
-                    </a:ln>
-                    <a:solidFill>
-                      <a:schemeClr val="tx1"/>
-                    </a:solidFill>
-                    <a:effectLst/>
-                    <a:latin typeface="Century Gothic" panose="020B0502020202020204" pitchFamily="34" charset="0"/>
-                  </a:rPr>
-                  <a:t>. Fit a polynomial of degree 7 to map time to the </a:t>
-                </a:r>
-                <a:r>
-                  <a:rPr lang="en-US" altLang="it-IT" sz="1400" dirty="0">
-                    <a:latin typeface="Century Gothic" panose="020B0502020202020204" pitchFamily="34" charset="0"/>
-                  </a:rPr>
-                  <a:t>arc</a:t>
-                </a:r>
-                <a:r>
-                  <a:rPr kumimoji="0" lang="en-US" altLang="it-IT" sz="1400" b="0" i="0" u="none" strike="noStrike" cap="none" normalizeH="0" baseline="0" dirty="0">
-                    <a:ln>
-                      <a:noFill/>
-                    </a:ln>
-                    <a:solidFill>
-                      <a:schemeClr val="tx1"/>
-                    </a:solidFill>
-                    <a:effectLst/>
-                    <a:latin typeface="Century Gothic" panose="020B0502020202020204" pitchFamily="34" charset="0"/>
-                  </a:rPr>
-                  <a:t>length. </a:t>
-                </a:r>
-                <a:r>
-                  <a:rPr kumimoji="0" lang="en-US" altLang="it-IT" sz="1400" b="0" u="none" strike="noStrike" cap="none" normalizeH="0" baseline="0" dirty="0" err="1">
-                    <a:ln>
-                      <a:noFill/>
-                    </a:ln>
-                    <a:solidFill>
-                      <a:schemeClr val="tx1"/>
-                    </a:solidFill>
-                    <a:effectLst/>
-                    <a:latin typeface="Courier New" panose="02070309020205020404" pitchFamily="49" charset="0"/>
-                    <a:cs typeface="Courier New" panose="02070309020205020404" pitchFamily="49" charset="0"/>
-                  </a:rPr>
-                  <a:t>polyfit</a:t>
-                </a:r>
-                <a:r>
-                  <a:rPr kumimoji="0" lang="en-US" altLang="it-IT" sz="1400" b="0" i="1" u="none" strike="noStrike" cap="none" normalizeH="0" baseline="0" dirty="0">
-                    <a:ln>
-                      <a:noFill/>
-                    </a:ln>
-                    <a:solidFill>
-                      <a:schemeClr val="tx1"/>
-                    </a:solidFill>
-                    <a:effectLst/>
-                    <a:latin typeface="Century Gothic" panose="020B0502020202020204" pitchFamily="34" charset="0"/>
-                  </a:rPr>
-                  <a:t> </a:t>
-                </a:r>
-                <a:r>
-                  <a:rPr lang="en-US" altLang="it-IT" sz="1400" dirty="0">
-                    <a:latin typeface="Century Gothic" panose="020B0502020202020204" pitchFamily="34" charset="0"/>
-                  </a:rPr>
-                  <a:t>and </a:t>
-                </a:r>
-                <a:r>
-                  <a:rPr lang="en-US" altLang="it-IT" sz="1400" dirty="0" err="1">
-                    <a:latin typeface="Courier New" panose="02070309020205020404" pitchFamily="49" charset="0"/>
-                    <a:cs typeface="Courier New" panose="02070309020205020404" pitchFamily="49" charset="0"/>
-                  </a:rPr>
-                  <a:t>polyval</a:t>
-                </a:r>
-                <a:r>
-                  <a:rPr lang="en-US" altLang="it-IT" sz="1400" i="1" dirty="0">
-                    <a:latin typeface="Century Gothic" panose="020B0502020202020204" pitchFamily="34" charset="0"/>
-                  </a:rPr>
-                  <a:t> </a:t>
-                </a:r>
-                <a:r>
-                  <a:rPr lang="en-US" altLang="it-IT" sz="1400" dirty="0">
-                    <a:latin typeface="Century Gothic" panose="020B0502020202020204" pitchFamily="34" charset="0"/>
-                  </a:rPr>
-                  <a:t>f</a:t>
-                </a:r>
-                <a:r>
-                  <a:rPr kumimoji="0" lang="en-US" altLang="it-IT" sz="1400" b="0" u="none" strike="noStrike" cap="none" normalizeH="0" baseline="0" dirty="0">
-                    <a:ln>
-                      <a:noFill/>
-                    </a:ln>
-                    <a:solidFill>
-                      <a:schemeClr val="tx1"/>
-                    </a:solidFill>
-                    <a:effectLst/>
-                    <a:latin typeface="Century Gothic" panose="020B0502020202020204" pitchFamily="34" charset="0"/>
-                  </a:rPr>
-                  <a:t>unctions in MATLAB </a:t>
-                </a:r>
-                <a:r>
-                  <a:rPr lang="en-US" altLang="it-IT" sz="1400" dirty="0">
-                    <a:latin typeface="Century Gothic" panose="020B0502020202020204" pitchFamily="34" charset="0"/>
-                  </a:rPr>
-                  <a:t>was used.</a:t>
-                </a:r>
-                <a:endParaRPr lang="it-IT" sz="1400" dirty="0"/>
-              </a:p>
-            </p:txBody>
-          </p:sp>
-        </mc:Choice>
-        <mc:Fallback xmlns="">
-          <p:sp>
-            <p:nvSpPr>
-              <p:cNvPr id="20" name="CasellaDiTesto 19">
-                <a:extLst>
-                  <a:ext uri="{FF2B5EF4-FFF2-40B4-BE49-F238E27FC236}">
-                    <a16:creationId xmlns:a16="http://schemas.microsoft.com/office/drawing/2014/main" id="{3B971298-8E67-0CC5-FD8C-AF79D7A1C506}"/>
-                  </a:ext>
-                </a:extLst>
-              </p:cNvPr>
-              <p:cNvSpPr txBox="1">
-                <a:spLocks noRot="1" noChangeAspect="1" noMove="1" noResize="1" noEditPoints="1" noAdjustHandles="1" noChangeArrowheads="1" noChangeShapeType="1" noTextEdit="1"/>
-              </p:cNvSpPr>
-              <p:nvPr/>
-            </p:nvSpPr>
-            <p:spPr>
-              <a:xfrm>
-                <a:off x="1364344" y="2595111"/>
-                <a:ext cx="4242450" cy="1169551"/>
-              </a:xfrm>
-              <a:prstGeom prst="rect">
-                <a:avLst/>
-              </a:prstGeom>
-              <a:blipFill>
-                <a:blip r:embed="rId10"/>
-                <a:stretch>
-                  <a:fillRect l="-431" t="-1042" b="-3646"/>
-                </a:stretch>
-              </a:blipFill>
-            </p:spPr>
-            <p:txBody>
-              <a:bodyPr/>
-              <a:lstStyle/>
-              <a:p>
-                <a:r>
-                  <a:rPr lang="it-IT">
-                    <a:noFill/>
-                  </a:rPr>
-                  <a:t> </a:t>
-                </a:r>
-              </a:p>
-            </p:txBody>
-          </p:sp>
-        </mc:Fallback>
-      </mc:AlternateContent>
+      <p:sp>
+        <p:nvSpPr>
+          <p:cNvPr id="20" name="CasellaDiTesto 19">
+            <a:extLst>
+              <a:ext uri="{FF2B5EF4-FFF2-40B4-BE49-F238E27FC236}">
+                <a16:creationId xmlns:a16="http://schemas.microsoft.com/office/drawing/2014/main" id="{3B971298-8E67-0CC5-FD8C-AF79D7A1C506}"/>
+              </a:ext>
+            </a:extLst>
+          </p:cNvPr>
+          <p:cNvSpPr txBox="1"/>
+          <p:nvPr/>
+        </p:nvSpPr>
+        <p:spPr>
+          <a:xfrm>
+            <a:off x="1364344" y="2595111"/>
+            <a:ext cx="4242450" cy="1169551"/>
+          </a:xfrm>
+          <a:prstGeom prst="rect">
+            <a:avLst/>
+          </a:prstGeom>
+          <a:noFill/>
+        </p:spPr>
+        <p:txBody>
+          <a:bodyPr wrap="square">
+            <a:spAutoFit/>
+          </a:bodyPr>
+          <a:lstStyle/>
+          <a:p>
+            <a:r>
+              <a:rPr lang="en-US" altLang="it-IT" sz="1400" dirty="0">
+                <a:latin typeface="Century Gothic" panose="020B0502020202020204" pitchFamily="34" charset="0"/>
+              </a:rPr>
+              <a:t>The time law 𝑠(𝑡) is defined as a function (polynomial of degree 7) that maps time 𝑡 to a parameter 𝑠 along the geometric path. The functions </a:t>
+            </a:r>
+            <a:r>
+              <a:rPr lang="en-US" altLang="it-IT" sz="1400" dirty="0" err="1">
+                <a:latin typeface="Courier New" panose="02070309020205020404" pitchFamily="49" charset="0"/>
+                <a:cs typeface="Courier New" panose="02070309020205020404" pitchFamily="49" charset="0"/>
+              </a:rPr>
+              <a:t>polyfit</a:t>
+            </a:r>
+            <a:r>
+              <a:rPr lang="en-US" altLang="it-IT" sz="1400" dirty="0">
+                <a:latin typeface="Century Gothic" panose="020B0502020202020204" pitchFamily="34" charset="0"/>
+              </a:rPr>
+              <a:t> and </a:t>
+            </a:r>
+            <a:r>
+              <a:rPr lang="en-US" altLang="it-IT" sz="1400" dirty="0" err="1">
+                <a:latin typeface="Courier New" panose="02070309020205020404" pitchFamily="49" charset="0"/>
+                <a:cs typeface="Courier New" panose="02070309020205020404" pitchFamily="49" charset="0"/>
+              </a:rPr>
+              <a:t>polyval</a:t>
+            </a:r>
+            <a:r>
+              <a:rPr lang="en-US" altLang="it-IT" sz="1400" dirty="0">
+                <a:latin typeface="Century Gothic" panose="020B0502020202020204" pitchFamily="34" charset="0"/>
+              </a:rPr>
+              <a:t> in MATLAB were utilized to generate this temporal profile.</a:t>
+            </a:r>
+            <a:endParaRPr lang="it-IT" sz="1400" dirty="0"/>
+          </a:p>
+        </p:txBody>
+      </p:sp>
       <p:sp>
         <p:nvSpPr>
           <p:cNvPr id="21" name="Ovale 20">
@@ -17719,7 +17698,7 @@
         </p:nvSpPr>
         <p:spPr>
           <a:xfrm>
-            <a:off x="5873085" y="3150577"/>
+            <a:off x="5873085" y="3038111"/>
             <a:ext cx="328076" cy="302080"/>
           </a:xfrm>
           <a:prstGeom prst="ellipse">
@@ -17797,7 +17776,7 @@
             </p:nvSpPr>
             <p:spPr>
               <a:xfrm>
-                <a:off x="6198477" y="3134849"/>
+                <a:off x="6183964" y="3020814"/>
                 <a:ext cx="3951219" cy="369332"/>
               </a:xfrm>
               <a:prstGeom prst="rect">
@@ -17903,16 +17882,16 @@
             </p:nvSpPr>
             <p:spPr>
               <a:xfrm>
-                <a:off x="6198477" y="3134849"/>
+                <a:off x="6183964" y="3020814"/>
                 <a:ext cx="3951219" cy="369332"/>
               </a:xfrm>
               <a:prstGeom prst="rect">
                 <a:avLst/>
               </a:prstGeom>
               <a:blipFill>
-                <a:blip r:embed="rId11"/>
+                <a:blip r:embed="rId10"/>
                 <a:stretch>
-                  <a:fillRect l="-1389" t="-8197" b="-24590"/>
+                  <a:fillRect l="-1233" t="-10000" b="-26667"/>
                 </a:stretch>
               </a:blipFill>
             </p:spPr>
@@ -17931,213 +17910,87 @@
           </p:sp>
         </mc:Fallback>
       </mc:AlternateContent>
-      <mc:AlternateContent xmlns:mc="http://schemas.openxmlformats.org/markup-compatibility/2006" xmlns:a14="http://schemas.microsoft.com/office/drawing/2010/main">
-        <mc:Choice Requires="a14">
-          <p:sp>
-            <p:nvSpPr>
-              <p:cNvPr id="38" name="CasellaDiTesto 37">
-                <a:extLst>
-                  <a:ext uri="{FF2B5EF4-FFF2-40B4-BE49-F238E27FC236}">
-                    <a16:creationId xmlns:a16="http://schemas.microsoft.com/office/drawing/2014/main" id="{2911841A-2B10-FA22-EF39-2D169A173764}"/>
-                  </a:ext>
-                </a:extLst>
-              </p:cNvPr>
-              <p:cNvSpPr txBox="1"/>
-              <p:nvPr/>
-            </p:nvSpPr>
-            <p:spPr>
-              <a:xfrm>
-                <a:off x="6183964" y="3456742"/>
-                <a:ext cx="3654854" cy="954107"/>
-              </a:xfrm>
-              <a:prstGeom prst="rect">
-                <a:avLst/>
-              </a:prstGeom>
-              <a:noFill/>
-            </p:spPr>
-            <p:txBody>
-              <a:bodyPr wrap="square">
-                <a:spAutoFit/>
-              </a:bodyPr>
-              <a:lstStyle/>
-              <a:p>
-                <a:pPr lvl="0" defTabSz="914400" eaLnBrk="0" fontAlgn="base" hangingPunct="0">
-                  <a:spcBef>
-                    <a:spcPct val="0"/>
-                  </a:spcBef>
-                  <a:spcAft>
-                    <a:spcPct val="0"/>
-                  </a:spcAft>
-                </a:pPr>
-                <a:r>
-                  <a:rPr lang="en-US" altLang="it-IT" sz="1400" dirty="0">
-                    <a:latin typeface="Century Gothic" panose="020B0502020202020204" pitchFamily="34" charset="0"/>
-                  </a:rPr>
-                  <a:t>Time law </a:t>
-                </a:r>
-                <a14:m>
-                  <m:oMath xmlns:m="http://schemas.openxmlformats.org/officeDocument/2006/math">
-                    <m:r>
-                      <a:rPr lang="it-IT" altLang="it-IT" sz="1400" i="1">
-                        <a:latin typeface="Cambria Math" panose="02040503050406030204" pitchFamily="18" charset="0"/>
-                      </a:rPr>
-                      <m:t>𝑠</m:t>
-                    </m:r>
-                    <m:r>
-                      <a:rPr lang="it-IT" altLang="it-IT" sz="1400" i="1">
-                        <a:latin typeface="Cambria Math" panose="02040503050406030204" pitchFamily="18" charset="0"/>
-                      </a:rPr>
-                      <m:t>(</m:t>
-                    </m:r>
-                    <m:r>
-                      <a:rPr lang="it-IT" altLang="it-IT" sz="1400" i="1">
-                        <a:latin typeface="Cambria Math" panose="02040503050406030204" pitchFamily="18" charset="0"/>
-                      </a:rPr>
-                      <m:t>𝑡</m:t>
-                    </m:r>
-                    <m:r>
-                      <a:rPr lang="it-IT" altLang="it-IT" sz="1400" i="1">
-                        <a:latin typeface="Cambria Math" panose="02040503050406030204" pitchFamily="18" charset="0"/>
-                      </a:rPr>
-                      <m:t>)</m:t>
-                    </m:r>
-                  </m:oMath>
-                </a14:m>
-                <a:r>
-                  <a:rPr lang="en-US" altLang="it-IT" sz="1400" dirty="0">
-                    <a:latin typeface="Century Gothic" panose="020B0502020202020204" pitchFamily="34" charset="0"/>
-                  </a:rPr>
-                  <a:t> is used to remap the values of the geometric path </a:t>
-                </a:r>
-                <a14:m>
-                  <m:oMath xmlns:m="http://schemas.openxmlformats.org/officeDocument/2006/math">
-                    <m:r>
-                      <a:rPr lang="it-IT" altLang="it-IT" sz="1400" i="1">
-                        <a:latin typeface="Cambria Math" panose="02040503050406030204" pitchFamily="18" charset="0"/>
-                      </a:rPr>
-                      <m:t>𝑥</m:t>
-                    </m:r>
-                    <m:r>
-                      <a:rPr lang="it-IT" altLang="it-IT" sz="1400" i="1">
-                        <a:latin typeface="Cambria Math" panose="02040503050406030204" pitchFamily="18" charset="0"/>
-                      </a:rPr>
-                      <m:t> </m:t>
-                    </m:r>
-                  </m:oMath>
-                </a14:m>
-                <a:r>
-                  <a:rPr lang="en-US" altLang="it-IT" sz="1400" dirty="0">
-                    <a:latin typeface="Century Gothic" panose="020B0502020202020204" pitchFamily="34" charset="0"/>
-                  </a:rPr>
-                  <a:t>and </a:t>
-                </a:r>
-                <a14:m>
-                  <m:oMath xmlns:m="http://schemas.openxmlformats.org/officeDocument/2006/math">
-                    <m:r>
-                      <a:rPr lang="it-IT" altLang="it-IT" sz="1400" i="1">
-                        <a:latin typeface="Cambria Math" panose="02040503050406030204" pitchFamily="18" charset="0"/>
-                      </a:rPr>
-                      <m:t>𝑦</m:t>
-                    </m:r>
-                  </m:oMath>
-                </a14:m>
-                <a:r>
-                  <a:rPr lang="it-IT" altLang="it-IT" sz="1400" dirty="0">
-                    <a:latin typeface="Century Gothic" panose="020B0502020202020204" pitchFamily="34" charset="0"/>
-                  </a:rPr>
-                  <a:t>. </a:t>
-                </a:r>
-                <a:r>
-                  <a:rPr lang="en-US" altLang="it-IT" sz="1400" dirty="0">
-                    <a:latin typeface="Courier New" panose="02070309020205020404" pitchFamily="49" charset="0"/>
-                    <a:cs typeface="Courier New" panose="02070309020205020404" pitchFamily="49" charset="0"/>
-                  </a:rPr>
-                  <a:t>interp1</a:t>
-                </a:r>
-                <a:r>
-                  <a:rPr lang="en-US" altLang="it-IT" sz="1400" i="1" dirty="0">
-                    <a:latin typeface="Century Gothic" panose="020B0502020202020204" pitchFamily="34" charset="0"/>
-                  </a:rPr>
-                  <a:t> </a:t>
-                </a:r>
-                <a:r>
-                  <a:rPr lang="en-US" altLang="it-IT" sz="1400" dirty="0">
-                    <a:latin typeface="Century Gothic" panose="020B0502020202020204" pitchFamily="34" charset="0"/>
-                  </a:rPr>
-                  <a:t>function with the </a:t>
-                </a:r>
-                <a:r>
-                  <a:rPr lang="en-US" altLang="it-IT" sz="1400" dirty="0">
-                    <a:latin typeface="Courier New" panose="02070309020205020404" pitchFamily="49" charset="0"/>
-                    <a:cs typeface="Courier New" panose="02070309020205020404" pitchFamily="49" charset="0"/>
-                  </a:rPr>
-                  <a:t>spline</a:t>
-                </a:r>
-                <a:r>
-                  <a:rPr lang="en-US" altLang="it-IT" sz="1400" dirty="0">
-                    <a:latin typeface="Century Gothic" panose="020B0502020202020204" pitchFamily="34" charset="0"/>
-                  </a:rPr>
-                  <a:t> option in MATLAB was used.</a:t>
-                </a:r>
-                <a:endParaRPr kumimoji="0" lang="en-US" altLang="it-IT" sz="1400" b="0" i="0" u="none" strike="noStrike" cap="none" normalizeH="0" baseline="0" dirty="0">
-                  <a:ln>
-                    <a:noFill/>
-                  </a:ln>
-                  <a:solidFill>
-                    <a:schemeClr val="tx1"/>
-                  </a:solidFill>
-                  <a:effectLst/>
-                  <a:latin typeface="Century Gothic" panose="020B0502020202020204" pitchFamily="34" charset="0"/>
-                </a:endParaRPr>
-              </a:p>
-            </p:txBody>
-          </p:sp>
-        </mc:Choice>
-        <mc:Fallback xmlns="">
-          <p:sp>
-            <p:nvSpPr>
-              <p:cNvPr id="38" name="CasellaDiTesto 37">
-                <a:extLst>
-                  <a:ext uri="{FF2B5EF4-FFF2-40B4-BE49-F238E27FC236}">
-                    <a16:creationId xmlns:a16="http://schemas.microsoft.com/office/drawing/2014/main" id="{2911841A-2B10-FA22-EF39-2D169A173764}"/>
-                  </a:ext>
-                </a:extLst>
-              </p:cNvPr>
-              <p:cNvSpPr txBox="1">
-                <a:spLocks noRot="1" noChangeAspect="1" noMove="1" noResize="1" noEditPoints="1" noAdjustHandles="1" noChangeArrowheads="1" noChangeShapeType="1" noTextEdit="1"/>
-              </p:cNvSpPr>
-              <p:nvPr/>
-            </p:nvSpPr>
-            <p:spPr>
-              <a:xfrm>
-                <a:off x="6183964" y="3456742"/>
-                <a:ext cx="3654854" cy="954107"/>
-              </a:xfrm>
-              <a:prstGeom prst="rect">
-                <a:avLst/>
-              </a:prstGeom>
-              <a:blipFill>
-                <a:blip r:embed="rId12"/>
-                <a:stretch>
-                  <a:fillRect l="-500" t="-1274" b="-5732"/>
-                </a:stretch>
-              </a:blipFill>
-            </p:spPr>
-            <p:txBody>
-              <a:bodyPr/>
-              <a:lstStyle/>
-              <a:p>
-                <a:r>
-                  <a:rPr lang="it-IT">
-                    <a:noFill/>
-                  </a:rPr>
-                  <a:t> </a:t>
-                </a:r>
-              </a:p>
-            </p:txBody>
-          </p:sp>
-        </mc:Fallback>
-      </mc:AlternateContent>
+      <p:sp>
+        <p:nvSpPr>
+          <p:cNvPr id="38" name="CasellaDiTesto 37">
+            <a:extLst>
+              <a:ext uri="{FF2B5EF4-FFF2-40B4-BE49-F238E27FC236}">
+                <a16:creationId xmlns:a16="http://schemas.microsoft.com/office/drawing/2014/main" id="{2911841A-2B10-FA22-EF39-2D169A173764}"/>
+              </a:ext>
+            </a:extLst>
+          </p:cNvPr>
+          <p:cNvSpPr txBox="1"/>
+          <p:nvPr/>
+        </p:nvSpPr>
+        <p:spPr>
+          <a:xfrm>
+            <a:off x="6183964" y="3344276"/>
+            <a:ext cx="6021528" cy="1169551"/>
+          </a:xfrm>
+          <a:prstGeom prst="rect">
+            <a:avLst/>
+          </a:prstGeom>
+          <a:noFill/>
+        </p:spPr>
+        <p:txBody>
+          <a:bodyPr wrap="square">
+            <a:spAutoFit/>
+          </a:bodyPr>
+          <a:lstStyle/>
+          <a:p>
+            <a:pPr lvl="0" defTabSz="914400" eaLnBrk="0" fontAlgn="base" hangingPunct="0">
+              <a:spcBef>
+                <a:spcPct val="0"/>
+              </a:spcBef>
+              <a:spcAft>
+                <a:spcPct val="0"/>
+              </a:spcAft>
+            </a:pPr>
+            <a:r>
+              <a:rPr lang="en-US" altLang="it-IT" sz="1400" dirty="0">
+                <a:latin typeface="Century Gothic" panose="020B0502020202020204" pitchFamily="34" charset="0"/>
+              </a:rPr>
+              <a:t>The time law 𝑠(𝑡) is used to remap the values of the geometric path 𝑥(𝑠) and 𝑦(𝑠) as functions of time 𝑡. The </a:t>
+            </a:r>
+            <a:r>
+              <a:rPr lang="en-US" altLang="it-IT" sz="1400" dirty="0">
+                <a:latin typeface="Courier New" panose="02070309020205020404" pitchFamily="49" charset="0"/>
+                <a:cs typeface="Courier New" panose="02070309020205020404" pitchFamily="49" charset="0"/>
+              </a:rPr>
+              <a:t>interp1</a:t>
+            </a:r>
+            <a:r>
+              <a:rPr lang="en-US" altLang="it-IT" sz="1400" dirty="0">
+                <a:latin typeface="Century Gothic" panose="020B0502020202020204" pitchFamily="34" charset="0"/>
+              </a:rPr>
+              <a:t> function with the </a:t>
+            </a:r>
+            <a:r>
+              <a:rPr lang="en-US" altLang="it-IT" sz="1400" dirty="0">
+                <a:latin typeface="Courier New" panose="02070309020205020404" pitchFamily="49" charset="0"/>
+                <a:cs typeface="Courier New" panose="02070309020205020404" pitchFamily="49" charset="0"/>
+              </a:rPr>
+              <a:t>spline</a:t>
+            </a:r>
+            <a:r>
+              <a:rPr lang="en-US" altLang="it-IT" sz="1400" dirty="0">
+                <a:latin typeface="Century Gothic" panose="020B0502020202020204" pitchFamily="34" charset="0"/>
+              </a:rPr>
+              <a:t> option in MATLAB is employed to interpolate the values of 𝑥(𝑠) and 𝑦(𝑠) over time, resulting in the temporal trajectories 𝑥(𝑡) and 𝑦(𝑡).</a:t>
+            </a:r>
+            <a:endParaRPr kumimoji="0" lang="en-US" altLang="it-IT" sz="1400" b="0" i="0" u="none" strike="noStrike" cap="none" normalizeH="0" baseline="0" dirty="0">
+              <a:ln>
+                <a:noFill/>
+              </a:ln>
+              <a:solidFill>
+                <a:schemeClr val="tx1"/>
+              </a:solidFill>
+              <a:effectLst/>
+              <a:latin typeface="Century Gothic" panose="020B0502020202020204" pitchFamily="34" charset="0"/>
+            </a:endParaRPr>
+          </a:p>
+        </p:txBody>
+      </p:sp>
       <p:cxnSp>
         <p:nvCxnSpPr>
           <p:cNvPr id="47" name="Connettore a gomito 46">
@@ -18154,12 +18007,12 @@
         </p:nvCxnSpPr>
         <p:spPr>
           <a:xfrm>
-            <a:off x="5719641" y="4863234"/>
-            <a:ext cx="792997" cy="773897"/>
+            <a:off x="3700331" y="5183955"/>
+            <a:ext cx="1906463" cy="592232"/>
           </a:xfrm>
           <a:prstGeom prst="bentConnector3">
             <a:avLst>
-              <a:gd name="adj1" fmla="val -1249"/>
+              <a:gd name="adj1" fmla="val -402"/>
             </a:avLst>
           </a:prstGeom>
           <a:ln w="28575">
@@ -18232,7 +18085,7 @@
     </p:spTree>
     <p:extLst>
       <p:ext uri="{BB962C8B-B14F-4D97-AF65-F5344CB8AC3E}">
-        <p14:creationId xmlns:p14="http://schemas.microsoft.com/office/powerpoint/2010/main" val="4248951617"/>
+        <p14:creationId xmlns:p14="http://schemas.microsoft.com/office/powerpoint/2010/main" val="761542931"/>
       </p:ext>
     </p:extLst>
   </p:cSld>
@@ -20408,7 +20261,7 @@
         <p:spPr>
           <a:xfrm>
             <a:off x="278286" y="4903208"/>
-            <a:ext cx="5156471" cy="369332"/>
+            <a:ext cx="5548240" cy="369332"/>
           </a:xfrm>
           <a:prstGeom prst="rect">
             <a:avLst/>
@@ -20425,7 +20278,7 @@
               <a:rPr lang="en-US" dirty="0">
                 <a:latin typeface="Century Gothic" panose="020B0502020202020204" pitchFamily="34" charset="0"/>
               </a:rPr>
-              <a:t>Heading velocity and angular velocity:</a:t>
+              <a:t>Heading velocity and steering angle velocity:</a:t>
             </a:r>
             <a:endParaRPr lang="it-IT" dirty="0">
               <a:latin typeface="Century Gothic" panose="020B0502020202020204" pitchFamily="34" charset="0"/>
@@ -30347,7 +30200,7 @@
         <p:spPr>
           <a:xfrm>
             <a:off x="1225934" y="5536409"/>
-            <a:ext cx="3381433" cy="646331"/>
+            <a:ext cx="3528946" cy="646331"/>
           </a:xfrm>
           <a:prstGeom prst="rect">
             <a:avLst/>
@@ -30364,7 +30217,19 @@
               <a:rPr lang="en-US" sz="1800" dirty="0">
                 <a:latin typeface="Century Gothic" panose="020B0502020202020204" pitchFamily="34" charset="0"/>
               </a:rPr>
-              <a:t>Heading velocity and angular velocity in MATLAB</a:t>
+              <a:t>Heading velocity and </a:t>
+            </a:r>
+            <a:r>
+              <a:rPr lang="en-US" dirty="0">
+                <a:latin typeface="Century Gothic" panose="020B0502020202020204" pitchFamily="34" charset="0"/>
+              </a:rPr>
+              <a:t>steering angle</a:t>
+            </a:r>
+            <a:r>
+              <a:rPr lang="en-US" sz="1800" dirty="0">
+                <a:latin typeface="Century Gothic" panose="020B0502020202020204" pitchFamily="34" charset="0"/>
+              </a:rPr>
+              <a:t> velocity in MATLAB</a:t>
             </a:r>
             <a:endParaRPr lang="it-IT" dirty="0"/>
           </a:p>
@@ -30443,7 +30308,7 @@
         <p:spPr>
           <a:xfrm>
             <a:off x="6997695" y="5530802"/>
-            <a:ext cx="3381433" cy="646331"/>
+            <a:ext cx="3528946" cy="646331"/>
           </a:xfrm>
           <a:prstGeom prst="rect">
             <a:avLst/>
@@ -30460,7 +30325,19 @@
               <a:rPr lang="en-US" sz="1800" dirty="0">
                 <a:latin typeface="Century Gothic" panose="020B0502020202020204" pitchFamily="34" charset="0"/>
               </a:rPr>
-              <a:t>Heading velocity and angular velocity in SIMULINK</a:t>
+              <a:t>Heading velocity and </a:t>
+            </a:r>
+            <a:r>
+              <a:rPr lang="en-US" dirty="0">
+                <a:latin typeface="Century Gothic" panose="020B0502020202020204" pitchFamily="34" charset="0"/>
+              </a:rPr>
+              <a:t>steering angle</a:t>
+            </a:r>
+            <a:r>
+              <a:rPr lang="en-US" sz="1800" dirty="0">
+                <a:latin typeface="Century Gothic" panose="020B0502020202020204" pitchFamily="34" charset="0"/>
+              </a:rPr>
+              <a:t> velocity in SIMULINK</a:t>
             </a:r>
             <a:endParaRPr lang="it-IT" dirty="0"/>
           </a:p>
@@ -32182,7 +32059,7 @@
         <p:spPr>
           <a:xfrm>
             <a:off x="1225934" y="5536409"/>
-            <a:ext cx="3381433" cy="646331"/>
+            <a:ext cx="3559426" cy="646331"/>
           </a:xfrm>
           <a:prstGeom prst="rect">
             <a:avLst/>
@@ -32199,7 +32076,19 @@
               <a:rPr lang="en-US" sz="1800" dirty="0">
                 <a:latin typeface="Century Gothic" panose="020B0502020202020204" pitchFamily="34" charset="0"/>
               </a:rPr>
-              <a:t>Heading velocity and angular velocity in MATLAB</a:t>
+              <a:t>Heading velocity and </a:t>
+            </a:r>
+            <a:r>
+              <a:rPr lang="en-US" dirty="0">
+                <a:latin typeface="Century Gothic" panose="020B0502020202020204" pitchFamily="34" charset="0"/>
+              </a:rPr>
+              <a:t>steering angle</a:t>
+            </a:r>
+            <a:r>
+              <a:rPr lang="en-US" sz="1800" dirty="0">
+                <a:latin typeface="Century Gothic" panose="020B0502020202020204" pitchFamily="34" charset="0"/>
+              </a:rPr>
+              <a:t> velocity in MATLAB</a:t>
             </a:r>
             <a:endParaRPr lang="it-IT" dirty="0"/>
           </a:p>
@@ -32278,7 +32167,7 @@
         <p:spPr>
           <a:xfrm>
             <a:off x="6997695" y="5530802"/>
-            <a:ext cx="3381433" cy="646331"/>
+            <a:ext cx="3559426" cy="646331"/>
           </a:xfrm>
           <a:prstGeom prst="rect">
             <a:avLst/>
@@ -32295,7 +32184,19 @@
               <a:rPr lang="en-US" sz="1800" dirty="0">
                 <a:latin typeface="Century Gothic" panose="020B0502020202020204" pitchFamily="34" charset="0"/>
               </a:rPr>
-              <a:t>Heading velocity and angular velocity in SIMULINK</a:t>
+              <a:t>Heading velocity and </a:t>
+            </a:r>
+            <a:r>
+              <a:rPr lang="en-US" dirty="0">
+                <a:latin typeface="Century Gothic" panose="020B0502020202020204" pitchFamily="34" charset="0"/>
+              </a:rPr>
+              <a:t>steering angle</a:t>
+            </a:r>
+            <a:r>
+              <a:rPr lang="en-US" sz="1800" dirty="0">
+                <a:latin typeface="Century Gothic" panose="020B0502020202020204" pitchFamily="34" charset="0"/>
+              </a:rPr>
+              <a:t> velocity in SIMULINK</a:t>
             </a:r>
             <a:endParaRPr lang="it-IT" dirty="0"/>
           </a:p>

</xml_diff>